<commit_message>
presentation: render the bmc-agent demo to a real video + embed it in the PPTX
The deck previously *called* the animation a "looping video" but actually
embedded a live iframe, and the single-slide agentic-prover.pptx fell back to
a static poster + hyperlink because no mp4 existed.

- Record the onepager animation to bmc-agent-demo.{webm,mp4} (1280x720, H.264
  yuv420p, ~38s loop) — Keynote/PowerPoint-compatible.
- bmc-agent.html now plays the real <video> (mp4 + webm fallback, poster,
  autoplay/muted/loop) instead of the iframe; standalone deck still linked for
  crisp vectors + presenter controls.
- Rebuild agentic-prover.pptx: build_ppt.py now embeds the playable movie
  (ppt/media/media1.mp4) so it plays in slideshow.
- Pin playwright tooling (package.json/lock); ignore node_modules + build
  intermediates.

Co-Authored-By: Claude Opus 4.8 (1M context) <noreply@anthropic.com>
</commit_message>
<xml_diff>
--- a/presentation/agentic-prover.pptx
+++ b/presentation/agentic-prover.pptx
@@ -5118,16 +5118,23 @@
       </p:sp>
       <p:pic>
         <p:nvPicPr>
-          <p:cNvPr id="47" name="Picture 46" descr="_demo_poster.png">
-            <a:hlinkClick r:id="rId3"/>
+          <p:cNvPr id="47" name="bmc-agent-demo.mp4">
+            <a:hlinkClick r:id="" action="ppaction://media"/>
           </p:cNvPr>
           <p:cNvPicPr>
             <a:picLocks noChangeAspect="1"/>
           </p:cNvPicPr>
-          <p:nvPr/>
+          <p:nvPr>
+            <a:videoFile r:link="rId3"/>
+            <p:extLst>
+              <p:ext uri="{DAA4B4D4-6D71-4841-9C94-3DE7FCFB9230}">
+                <p14:media xmlns:p14="http://schemas.microsoft.com/office/powerpoint/2010/main" r:embed="rId2"/>
+              </p:ext>
+            </p:extLst>
+          </p:nvPr>
         </p:nvPicPr>
         <p:blipFill>
-          <a:blip r:embed="rId2"/>
+          <a:blip r:embed="rId4"/>
           <a:stretch>
             <a:fillRect/>
           </a:stretch>
@@ -5176,7 +5183,7 @@
                 </a:solidFill>
                 <a:latin typeface="Calibri"/>
               </a:rPr>
-              <a:t>▶ Click to play the live demo (bmc-agent.html)</a:t>
+              <a:t>▶ Embedded video — plays in slideshow</a:t>
             </a:r>
           </a:p>
         </p:txBody>
@@ -5225,6 +5232,28 @@
   <p:clrMapOvr>
     <a:masterClrMapping/>
   </p:clrMapOvr>
+  <p:timing>
+    <p:tnLst>
+      <p:par>
+        <p:cTn id="1" dur="indefinite" restart="never" nodeType="tmRoot">
+          <p:childTnLst>
+            <p:video>
+              <p:cMediaNode vol="80000">
+                <p:cTn id="2" fill="hold" display="0">
+                  <p:stCondLst>
+                    <p:cond delay="indefinite"/>
+                  </p:stCondLst>
+                </p:cTn>
+                <p:tgtEl>
+                  <p:spTgt spid="47"/>
+                </p:tgtEl>
+              </p:cMediaNode>
+            </p:video>
+          </p:childTnLst>
+        </p:cTn>
+      </p:par>
+    </p:tnLst>
+  </p:timing>
 </p:sld>
 </file>
 

</xml_diff>

<commit_message>
presentation: make the PPTX a high-level poster, not a copy of the video
The slide previously repeated the video's content (3-move pipeline, the
composition example, the confidence tiers) — redundant with the embedded demo.

Redesign as a single high-level statement of the idea:
- thesis: "AI writes the code. AProver proves it correct."
- one line of the design principle (agents propose, conventional tools dispose)
- the demo video as the hero (it carries all the mechanism detail)
- project link + scannable QR to github.com/agentic-prover/aprover, plus the
  paper reference (arXiv:2605.21434)

QR verified to decode to the repo URL. Movie still embedded (plays in slideshow).

Co-Authored-By: Claude Opus 4.8 (1M context) <noreply@anthropic.com>
</commit_message>
<xml_diff>
--- a/presentation/agentic-prover.pptx
+++ b/presentation/agentic-prover.pptx
@@ -3104,8 +3104,8 @@
         </p:nvSpPr>
         <p:spPr>
           <a:xfrm>
-            <a:off x="502920" y="384048"/>
-            <a:ext cx="146304" cy="146304"/>
+            <a:off x="548640" y="457200"/>
+            <a:ext cx="164592" cy="164592"/>
           </a:xfrm>
           <a:prstGeom prst="ellipse">
             <a:avLst/>
@@ -3148,8 +3148,8 @@
         </p:nvSpPr>
         <p:spPr>
           <a:xfrm>
-            <a:off x="713232" y="292608"/>
-            <a:ext cx="4572000" cy="365760"/>
+            <a:off x="786384" y="365760"/>
+            <a:ext cx="8229600" cy="365760"/>
           </a:xfrm>
           <a:prstGeom prst="rect">
             <a:avLst/>
@@ -3168,13 +3168,13 @@
               </a:lnSpc>
             </a:pPr>
             <a:r>
-              <a:rPr sz="1600" b="1">
+              <a:rPr sz="1900" b="1">
                 <a:solidFill>
                   <a:srgbClr val="E6EDF3"/>
                 </a:solidFill>
                 <a:latin typeface="Consolas"/>
               </a:rPr>
-              <a:t>agentic-prover</a:t>
+              <a:t>AProver</a:t>
             </a:r>
             <a:r>
               <a:rPr sz="1300" b="0">
@@ -3183,7 +3183,7 @@
                 </a:solidFill>
                 <a:latin typeface="Consolas"/>
               </a:rPr>
-              <a:t>   ·  agentic model checking</a:t>
+              <a:t>   ·  agentic prover for AI-generated code</a:t>
             </a:r>
           </a:p>
         </p:txBody>
@@ -3196,8 +3196,8 @@
         </p:nvSpPr>
         <p:spPr>
           <a:xfrm>
-            <a:off x="502920" y="841248"/>
-            <a:ext cx="7863840" cy="1371600"/>
+            <a:off x="548640" y="1463040"/>
+            <a:ext cx="5257800" cy="640080"/>
           </a:xfrm>
           <a:prstGeom prst="rect">
             <a:avLst/>
@@ -3212,36 +3212,17 @@
           <a:p>
             <a:pPr algn="l">
               <a:lnSpc>
-                <a:spcPct val="98000"/>
+                <a:spcPct val="100000"/>
               </a:lnSpc>
             </a:pPr>
             <a:r>
-              <a:rPr sz="3800" b="1">
+              <a:rPr sz="2900" b="1">
                 <a:solidFill>
                   <a:srgbClr val="E6EDF3"/>
                 </a:solidFill>
                 <a:latin typeface="Calibri"/>
               </a:rPr>
-              <a:t>Who verifies the code </a:t>
-            </a:r>
-            <a:r>
-              <a:rPr sz="1400" b="0">
-                <a:solidFill>
-                  <a:srgbClr val="E6EDF3"/>
-                </a:solidFill>
-                <a:latin typeface="Calibri"/>
-              </a:rPr>
-              <a:t>
-</a:t>
-            </a:r>
-            <a:r>
-              <a:rPr sz="3800" b="1">
-                <a:solidFill>
-                  <a:srgbClr val="58A6FF"/>
-                </a:solidFill>
-                <a:latin typeface="Calibri"/>
-              </a:rPr>
-              <a:t>the AI just wrote?</a:t>
+              <a:t>AI writes the code.</a:t>
             </a:r>
           </a:p>
         </p:txBody>
@@ -3254,8 +3235,8 @@
         </p:nvSpPr>
         <p:spPr>
           <a:xfrm>
-            <a:off x="521207" y="1993392"/>
-            <a:ext cx="7863840" cy="548640"/>
+            <a:off x="548640" y="2103120"/>
+            <a:ext cx="5257800" cy="640080"/>
           </a:xfrm>
           <a:prstGeom prst="rect">
             <a:avLst/>
@@ -3274,109 +3255,36 @@
               </a:lnSpc>
             </a:pPr>
             <a:r>
-              <a:rPr sz="1400" b="0">
+              <a:rPr sz="2900" b="1">
                 <a:solidFill>
-                  <a:srgbClr val="8B949E"/>
+                  <a:srgbClr val="E6EDF3"/>
                 </a:solidFill>
                 <a:latin typeface="Calibri"/>
               </a:rPr>
-              <a:t>LLM-synthesized specs  </a:t>
-            </a:r>
-            <a:r>
-              <a:rPr sz="1400" b="1">
+              <a:t>AProver proves it </a:t>
+            </a:r>
+            <a:r>
+              <a:rPr sz="2900" b="1">
                 <a:solidFill>
-                  <a:srgbClr val="A371F7"/>
+                  <a:srgbClr val="58A6FF"/>
                 </a:solidFill>
                 <a:latin typeface="Calibri"/>
               </a:rPr>
-              <a:t>×</a:t>
-            </a:r>
-            <a:r>
-              <a:rPr sz="1400" b="0">
-                <a:solidFill>
-                  <a:srgbClr val="8B949E"/>
-                </a:solidFill>
-                <a:latin typeface="Calibri"/>
-              </a:rPr>
-              <a:t>  bounded model checking  </a:t>
-            </a:r>
-            <a:r>
-              <a:rPr sz="1400" b="1">
-                <a:solidFill>
-                  <a:srgbClr val="A371F7"/>
-                </a:solidFill>
-                <a:latin typeface="Calibri"/>
-              </a:rPr>
-              <a:t>×</a:t>
-            </a:r>
-            <a:r>
-              <a:rPr sz="1400" b="0">
-                <a:solidFill>
-                  <a:srgbClr val="8B949E"/>
-                </a:solidFill>
-                <a:latin typeface="Calibri"/>
-              </a:rPr>
-              <a:t>  CEGAR refinement</a:t>
-            </a:r>
-          </a:p>
-        </p:txBody>
-      </p:sp>
-      <p:sp>
-        <p:nvSpPr>
-          <p:cNvPr id="6" name="Rounded Rectangle 5"/>
-          <p:cNvSpPr/>
+              <a:t>correct.</a:t>
+            </a:r>
+          </a:p>
+        </p:txBody>
+      </p:sp>
+      <p:sp>
+        <p:nvSpPr>
+          <p:cNvPr id="6" name="TextBox 5"/>
+          <p:cNvSpPr txBox="1"/>
           <p:nvPr/>
         </p:nvSpPr>
         <p:spPr>
           <a:xfrm>
-            <a:off x="502920" y="2542032"/>
-            <a:ext cx="2212848" cy="1078992"/>
-          </a:xfrm>
-          <a:prstGeom prst="roundRect">
-            <a:avLst/>
-          </a:prstGeom>
-          <a:solidFill>
-            <a:srgbClr val="161B22"/>
-          </a:solidFill>
-          <a:ln w="19050">
-            <a:solidFill>
-              <a:srgbClr val="A371F7"/>
-            </a:solidFill>
-          </a:ln>
-          <a:effectLst/>
-        </p:spPr>
-        <p:style>
-          <a:lnRef idx="1">
-            <a:schemeClr val="accent1"/>
-          </a:lnRef>
-          <a:fillRef idx="3">
-            <a:schemeClr val="accent1"/>
-          </a:fillRef>
-          <a:effectRef idx="2">
-            <a:schemeClr val="accent1"/>
-          </a:effectRef>
-          <a:fontRef idx="minor">
-            <a:schemeClr val="lt1"/>
-          </a:fontRef>
-        </p:style>
-        <p:txBody>
-          <a:bodyPr rtlCol="0" anchor="ctr"/>
-          <a:lstStyle/>
-          <a:p>
-            <a:pPr algn="ctr"/>
-          </a:p>
-        </p:txBody>
-      </p:sp>
-      <p:sp>
-        <p:nvSpPr>
-          <p:cNvPr id="7" name="TextBox 6"/>
-          <p:cNvSpPr txBox="1"/>
-          <p:nvPr/>
-        </p:nvSpPr>
-        <p:spPr>
-          <a:xfrm>
-            <a:off x="667512" y="2651760"/>
-            <a:ext cx="1938528" cy="274320"/>
+            <a:off x="548640" y="3063240"/>
+            <a:ext cx="5257800" cy="1188720"/>
           </a:xfrm>
           <a:prstGeom prst="rect">
             <a:avLst/>
@@ -3391,40 +3299,58 @@
           <a:p>
             <a:pPr algn="l">
               <a:lnSpc>
-                <a:spcPct val="100000"/>
+                <a:spcPct val="112000"/>
               </a:lnSpc>
             </a:pPr>
             <a:r>
-              <a:rPr sz="1600" b="1">
+              <a:rPr sz="1550" b="1">
                 <a:solidFill>
                   <a:srgbClr val="A371F7"/>
                 </a:solidFill>
-                <a:latin typeface="Consolas"/>
+                <a:latin typeface="Calibri"/>
               </a:rPr>
-              <a:t>✦  </a:t>
-            </a:r>
-            <a:r>
-              <a:rPr sz="1050" b="0">
+              <a:t>Agents propose</a:t>
+            </a:r>
+            <a:r>
+              <a:rPr sz="1550" b="0">
                 <a:solidFill>
                   <a:srgbClr val="8B949E"/>
                 </a:solidFill>
-                <a:latin typeface="Consolas"/>
+                <a:latin typeface="Calibri"/>
               </a:rPr>
-              <a:t>01 · synthesize</a:t>
-            </a:r>
-          </a:p>
-        </p:txBody>
-      </p:sp>
-      <p:sp>
-        <p:nvSpPr>
-          <p:cNvPr id="8" name="TextBox 7"/>
+              <a:t> — specifications, counterexample verdicts, refinements.  </a:t>
+            </a:r>
+            <a:r>
+              <a:rPr sz="1550" b="1">
+                <a:solidFill>
+                  <a:srgbClr val="58A6FF"/>
+                </a:solidFill>
+                <a:latin typeface="Calibri"/>
+              </a:rPr>
+              <a:t>Conventional tools dispose</a:t>
+            </a:r>
+            <a:r>
+              <a:rPr sz="1550" b="0">
+                <a:solidFill>
+                  <a:srgbClr val="8B949E"/>
+                </a:solidFill>
+                <a:latin typeface="Calibri"/>
+              </a:rPr>
+              <a:t> — every soundness-relevant claim passes a formal check before it counts.</a:t>
+            </a:r>
+          </a:p>
+        </p:txBody>
+      </p:sp>
+      <p:sp>
+        <p:nvSpPr>
+          <p:cNvPr id="7" name="TextBox 6"/>
           <p:cNvSpPr txBox="1"/>
           <p:nvPr/>
         </p:nvSpPr>
         <p:spPr>
           <a:xfrm>
-            <a:off x="667512" y="2962656"/>
-            <a:ext cx="1938528" cy="365760"/>
+            <a:off x="548640" y="4370832"/>
+            <a:ext cx="5257800" cy="365760"/>
           </a:xfrm>
           <a:prstGeom prst="rect">
             <a:avLst/>
@@ -3443,1008 +3369,51 @@
               </a:lnSpc>
             </a:pPr>
             <a:r>
-              <a:rPr sz="1450" b="1">
-                <a:solidFill>
-                  <a:srgbClr val="E6EDF3"/>
-                </a:solidFill>
-                <a:latin typeface="Calibri"/>
-              </a:rPr>
-              <a:t>LLM spec synthesis</a:t>
-            </a:r>
-          </a:p>
-        </p:txBody>
-      </p:sp>
-      <p:sp>
-        <p:nvSpPr>
-          <p:cNvPr id="9" name="TextBox 8"/>
-          <p:cNvSpPr txBox="1"/>
-          <p:nvPr/>
-        </p:nvSpPr>
-        <p:spPr>
-          <a:xfrm>
-            <a:off x="667512" y="3291839"/>
-            <a:ext cx="1938528" cy="274320"/>
-          </a:xfrm>
-          <a:prstGeom prst="rect">
-            <a:avLst/>
-          </a:prstGeom>
-          <a:noFill/>
-        </p:spPr>
-        <p:txBody>
-          <a:bodyPr wrap="square" anchor="t" lIns="25400" rIns="25400" tIns="12700" bIns="12700">
-            <a:spAutoFit/>
-          </a:bodyPr>
-          <a:lstStyle/>
-          <a:p>
-            <a:pPr algn="l">
-              <a:lnSpc>
-                <a:spcPct val="100000"/>
-              </a:lnSpc>
-            </a:pPr>
-            <a:r>
-              <a:rPr sz="1100" b="0">
+              <a:rPr sz="1550" b="0">
                 <a:solidFill>
                   <a:srgbClr val="8B949E"/>
                 </a:solidFill>
                 <a:latin typeface="Calibri"/>
               </a:rPr>
-              <a:t>pre / post-conditions</a:t>
-            </a:r>
-          </a:p>
-        </p:txBody>
-      </p:sp>
-      <p:sp>
-        <p:nvSpPr>
-          <p:cNvPr id="10" name="Rounded Rectangle 9"/>
+              <a:t>Bugs are </a:t>
+            </a:r>
+            <a:r>
+              <a:rPr sz="1550" b="1">
+                <a:solidFill>
+                  <a:srgbClr val="3FB950"/>
+                </a:solidFill>
+                <a:latin typeface="Calibri"/>
+              </a:rPr>
+              <a:t>confirmed, not guessed</a:t>
+            </a:r>
+            <a:r>
+              <a:rPr sz="1550" b="0">
+                <a:solidFill>
+                  <a:srgbClr val="8B949E"/>
+                </a:solidFill>
+                <a:latin typeface="Calibri"/>
+              </a:rPr>
+              <a:t>.</a:t>
+            </a:r>
+          </a:p>
+        </p:txBody>
+      </p:sp>
+      <p:sp>
+        <p:nvSpPr>
+          <p:cNvPr id="8" name="Rounded Rectangle 7"/>
           <p:cNvSpPr/>
           <p:nvPr/>
         </p:nvSpPr>
         <p:spPr>
           <a:xfrm>
-            <a:off x="3017520" y="2542032"/>
-            <a:ext cx="2212848" cy="1078992"/>
+            <a:off x="493776" y="5020056"/>
+            <a:ext cx="1527048" cy="1527048"/>
           </a:xfrm>
           <a:prstGeom prst="roundRect">
             <a:avLst/>
           </a:prstGeom>
           <a:solidFill>
-            <a:srgbClr val="161B22"/>
-          </a:solidFill>
-          <a:ln w="19050">
-            <a:solidFill>
-              <a:srgbClr val="58A6FF"/>
-            </a:solidFill>
-          </a:ln>
-          <a:effectLst/>
-        </p:spPr>
-        <p:style>
-          <a:lnRef idx="1">
-            <a:schemeClr val="accent1"/>
-          </a:lnRef>
-          <a:fillRef idx="3">
-            <a:schemeClr val="accent1"/>
-          </a:fillRef>
-          <a:effectRef idx="2">
-            <a:schemeClr val="accent1"/>
-          </a:effectRef>
-          <a:fontRef idx="minor">
-            <a:schemeClr val="lt1"/>
-          </a:fontRef>
-        </p:style>
-        <p:txBody>
-          <a:bodyPr rtlCol="0" anchor="ctr"/>
-          <a:lstStyle/>
-          <a:p>
-            <a:pPr algn="ctr"/>
-          </a:p>
-        </p:txBody>
-      </p:sp>
-      <p:sp>
-        <p:nvSpPr>
-          <p:cNvPr id="11" name="TextBox 10"/>
-          <p:cNvSpPr txBox="1"/>
-          <p:nvPr/>
-        </p:nvSpPr>
-        <p:spPr>
-          <a:xfrm>
-            <a:off x="3182112" y="2651760"/>
-            <a:ext cx="1938528" cy="274320"/>
-          </a:xfrm>
-          <a:prstGeom prst="rect">
-            <a:avLst/>
-          </a:prstGeom>
-          <a:noFill/>
-        </p:spPr>
-        <p:txBody>
-          <a:bodyPr wrap="square" anchor="t" lIns="25400" rIns="25400" tIns="12700" bIns="12700">
-            <a:spAutoFit/>
-          </a:bodyPr>
-          <a:lstStyle/>
-          <a:p>
-            <a:pPr algn="l">
-              <a:lnSpc>
-                <a:spcPct val="100000"/>
-              </a:lnSpc>
-            </a:pPr>
-            <a:r>
-              <a:rPr sz="1600" b="1">
-                <a:solidFill>
-                  <a:srgbClr val="58A6FF"/>
-                </a:solidFill>
-                <a:latin typeface="Consolas"/>
-              </a:rPr>
-              <a:t>⚙  </a:t>
-            </a:r>
-            <a:r>
-              <a:rPr sz="1050" b="0">
-                <a:solidFill>
-                  <a:srgbClr val="8B949E"/>
-                </a:solidFill>
-                <a:latin typeface="Consolas"/>
-              </a:rPr>
-              <a:t>02 · check</a:t>
-            </a:r>
-          </a:p>
-        </p:txBody>
-      </p:sp>
-      <p:sp>
-        <p:nvSpPr>
-          <p:cNvPr id="12" name="TextBox 11"/>
-          <p:cNvSpPr txBox="1"/>
-          <p:nvPr/>
-        </p:nvSpPr>
-        <p:spPr>
-          <a:xfrm>
-            <a:off x="3182112" y="2962656"/>
-            <a:ext cx="1938528" cy="365760"/>
-          </a:xfrm>
-          <a:prstGeom prst="rect">
-            <a:avLst/>
-          </a:prstGeom>
-          <a:noFill/>
-        </p:spPr>
-        <p:txBody>
-          <a:bodyPr wrap="square" anchor="t" lIns="25400" rIns="25400" tIns="12700" bIns="12700">
-            <a:spAutoFit/>
-          </a:bodyPr>
-          <a:lstStyle/>
-          <a:p>
-            <a:pPr algn="l">
-              <a:lnSpc>
-                <a:spcPct val="100000"/>
-              </a:lnSpc>
-            </a:pPr>
-            <a:r>
-              <a:rPr sz="1450" b="1">
-                <a:solidFill>
-                  <a:srgbClr val="E6EDF3"/>
-                </a:solidFill>
-                <a:latin typeface="Calibri"/>
-              </a:rPr>
-              <a:t>Bounded model check</a:t>
-            </a:r>
-          </a:p>
-        </p:txBody>
-      </p:sp>
-      <p:sp>
-        <p:nvSpPr>
-          <p:cNvPr id="13" name="TextBox 12"/>
-          <p:cNvSpPr txBox="1"/>
-          <p:nvPr/>
-        </p:nvSpPr>
-        <p:spPr>
-          <a:xfrm>
-            <a:off x="3182112" y="3291839"/>
-            <a:ext cx="1938528" cy="274320"/>
-          </a:xfrm>
-          <a:prstGeom prst="rect">
-            <a:avLst/>
-          </a:prstGeom>
-          <a:noFill/>
-        </p:spPr>
-        <p:txBody>
-          <a:bodyPr wrap="square" anchor="t" lIns="25400" rIns="25400" tIns="12700" bIns="12700">
-            <a:spAutoFit/>
-          </a:bodyPr>
-          <a:lstStyle/>
-          <a:p>
-            <a:pPr algn="l">
-              <a:lnSpc>
-                <a:spcPct val="100000"/>
-              </a:lnSpc>
-            </a:pPr>
-            <a:r>
-              <a:rPr sz="1100" b="0">
-                <a:solidFill>
-                  <a:srgbClr val="8B949E"/>
-                </a:solidFill>
-                <a:latin typeface="Calibri"/>
-              </a:rPr>
-              <a:t>CBMC · Kani</a:t>
-            </a:r>
-          </a:p>
-        </p:txBody>
-      </p:sp>
-      <p:sp>
-        <p:nvSpPr>
-          <p:cNvPr id="14" name="Rounded Rectangle 13"/>
-          <p:cNvSpPr/>
-          <p:nvPr/>
-        </p:nvSpPr>
-        <p:spPr>
-          <a:xfrm>
-            <a:off x="5532120" y="2542032"/>
-            <a:ext cx="2212848" cy="1078992"/>
-          </a:xfrm>
-          <a:prstGeom prst="roundRect">
-            <a:avLst/>
-          </a:prstGeom>
-          <a:solidFill>
-            <a:srgbClr val="161B22"/>
-          </a:solidFill>
-          <a:ln w="19050">
-            <a:solidFill>
-              <a:srgbClr val="3FB950"/>
-            </a:solidFill>
-          </a:ln>
-          <a:effectLst/>
-        </p:spPr>
-        <p:style>
-          <a:lnRef idx="1">
-            <a:schemeClr val="accent1"/>
-          </a:lnRef>
-          <a:fillRef idx="3">
-            <a:schemeClr val="accent1"/>
-          </a:fillRef>
-          <a:effectRef idx="2">
-            <a:schemeClr val="accent1"/>
-          </a:effectRef>
-          <a:fontRef idx="minor">
-            <a:schemeClr val="lt1"/>
-          </a:fontRef>
-        </p:style>
-        <p:txBody>
-          <a:bodyPr rtlCol="0" anchor="ctr"/>
-          <a:lstStyle/>
-          <a:p>
-            <a:pPr algn="ctr"/>
-          </a:p>
-        </p:txBody>
-      </p:sp>
-      <p:sp>
-        <p:nvSpPr>
-          <p:cNvPr id="15" name="TextBox 14"/>
-          <p:cNvSpPr txBox="1"/>
-          <p:nvPr/>
-        </p:nvSpPr>
-        <p:spPr>
-          <a:xfrm>
-            <a:off x="5696712" y="2651760"/>
-            <a:ext cx="1938528" cy="274320"/>
-          </a:xfrm>
-          <a:prstGeom prst="rect">
-            <a:avLst/>
-          </a:prstGeom>
-          <a:noFill/>
-        </p:spPr>
-        <p:txBody>
-          <a:bodyPr wrap="square" anchor="t" lIns="25400" rIns="25400" tIns="12700" bIns="12700">
-            <a:spAutoFit/>
-          </a:bodyPr>
-          <a:lstStyle/>
-          <a:p>
-            <a:pPr algn="l">
-              <a:lnSpc>
-                <a:spcPct val="100000"/>
-              </a:lnSpc>
-            </a:pPr>
-            <a:r>
-              <a:rPr sz="1600" b="1">
-                <a:solidFill>
-                  <a:srgbClr val="3FB950"/>
-                </a:solidFill>
-                <a:latin typeface="Consolas"/>
-              </a:rPr>
-              <a:t>⚖  </a:t>
-            </a:r>
-            <a:r>
-              <a:rPr sz="1050" b="0">
-                <a:solidFill>
-                  <a:srgbClr val="8B949E"/>
-                </a:solidFill>
-                <a:latin typeface="Consolas"/>
-              </a:rPr>
-              <a:t>03 · classify</a:t>
-            </a:r>
-          </a:p>
-        </p:txBody>
-      </p:sp>
-      <p:sp>
-        <p:nvSpPr>
-          <p:cNvPr id="16" name="TextBox 15"/>
-          <p:cNvSpPr txBox="1"/>
-          <p:nvPr/>
-        </p:nvSpPr>
-        <p:spPr>
-          <a:xfrm>
-            <a:off x="5696712" y="2962656"/>
-            <a:ext cx="1938528" cy="365760"/>
-          </a:xfrm>
-          <a:prstGeom prst="rect">
-            <a:avLst/>
-          </a:prstGeom>
-          <a:noFill/>
-        </p:spPr>
-        <p:txBody>
-          <a:bodyPr wrap="square" anchor="t" lIns="25400" rIns="25400" tIns="12700" bIns="12700">
-            <a:spAutoFit/>
-          </a:bodyPr>
-          <a:lstStyle/>
-          <a:p>
-            <a:pPr algn="l">
-              <a:lnSpc>
-                <a:spcPct val="100000"/>
-              </a:lnSpc>
-            </a:pPr>
-            <a:r>
-              <a:rPr sz="1450" b="1">
-                <a:solidFill>
-                  <a:srgbClr val="E6EDF3"/>
-                </a:solidFill>
-                <a:latin typeface="Calibri"/>
-              </a:rPr>
-              <a:t>Classify counterexample</a:t>
-            </a:r>
-          </a:p>
-        </p:txBody>
-      </p:sp>
-      <p:sp>
-        <p:nvSpPr>
-          <p:cNvPr id="17" name="TextBox 16"/>
-          <p:cNvSpPr txBox="1"/>
-          <p:nvPr/>
-        </p:nvSpPr>
-        <p:spPr>
-          <a:xfrm>
-            <a:off x="5696712" y="3291839"/>
-            <a:ext cx="1938528" cy="274320"/>
-          </a:xfrm>
-          <a:prstGeom prst="rect">
-            <a:avLst/>
-          </a:prstGeom>
-          <a:noFill/>
-        </p:spPr>
-        <p:txBody>
-          <a:bodyPr wrap="square" anchor="t" lIns="25400" rIns="25400" tIns="12700" bIns="12700">
-            <a:spAutoFit/>
-          </a:bodyPr>
-          <a:lstStyle/>
-          <a:p>
-            <a:pPr algn="l">
-              <a:lnSpc>
-                <a:spcPct val="100000"/>
-              </a:lnSpc>
-            </a:pPr>
-            <a:r>
-              <a:rPr sz="1100" b="0">
-                <a:solidFill>
-                  <a:srgbClr val="8B949E"/>
-                </a:solidFill>
-                <a:latin typeface="Calibri"/>
-              </a:rPr>
-              <a:t>real bug vs false alarm</a:t>
-            </a:r>
-          </a:p>
-        </p:txBody>
-      </p:sp>
-      <p:sp>
-        <p:nvSpPr>
-          <p:cNvPr id="18" name="Right Arrow 17"/>
-          <p:cNvSpPr/>
-          <p:nvPr/>
-        </p:nvSpPr>
-        <p:spPr>
-          <a:xfrm>
-            <a:off x="2734056" y="2980944"/>
-            <a:ext cx="265176" cy="201168"/>
-          </a:xfrm>
-          <a:prstGeom prst="rightArrow">
-            <a:avLst/>
-          </a:prstGeom>
-          <a:solidFill>
-            <a:srgbClr val="58A6FF"/>
-          </a:solidFill>
-          <a:ln>
-            <a:noFill/>
-          </a:ln>
-          <a:effectLst/>
-        </p:spPr>
-        <p:style>
-          <a:lnRef idx="1">
-            <a:schemeClr val="accent1"/>
-          </a:lnRef>
-          <a:fillRef idx="3">
-            <a:schemeClr val="accent1"/>
-          </a:fillRef>
-          <a:effectRef idx="2">
-            <a:schemeClr val="accent1"/>
-          </a:effectRef>
-          <a:fontRef idx="minor">
-            <a:schemeClr val="lt1"/>
-          </a:fontRef>
-        </p:style>
-        <p:txBody>
-          <a:bodyPr rtlCol="0" anchor="ctr"/>
-          <a:lstStyle/>
-          <a:p>
-            <a:pPr algn="ctr"/>
-          </a:p>
-        </p:txBody>
-      </p:sp>
-      <p:sp>
-        <p:nvSpPr>
-          <p:cNvPr id="19" name="Right Arrow 18"/>
-          <p:cNvSpPr/>
-          <p:nvPr/>
-        </p:nvSpPr>
-        <p:spPr>
-          <a:xfrm>
-            <a:off x="5248655" y="2980944"/>
-            <a:ext cx="265176" cy="201168"/>
-          </a:xfrm>
-          <a:prstGeom prst="rightArrow">
-            <a:avLst/>
-          </a:prstGeom>
-          <a:solidFill>
-            <a:srgbClr val="58A6FF"/>
-          </a:solidFill>
-          <a:ln>
-            <a:noFill/>
-          </a:ln>
-          <a:effectLst/>
-        </p:spPr>
-        <p:style>
-          <a:lnRef idx="1">
-            <a:schemeClr val="accent1"/>
-          </a:lnRef>
-          <a:fillRef idx="3">
-            <a:schemeClr val="accent1"/>
-          </a:fillRef>
-          <a:effectRef idx="2">
-            <a:schemeClr val="accent1"/>
-          </a:effectRef>
-          <a:fontRef idx="minor">
-            <a:schemeClr val="lt1"/>
-          </a:fontRef>
-        </p:style>
-        <p:txBody>
-          <a:bodyPr rtlCol="0" anchor="ctr"/>
-          <a:lstStyle/>
-          <a:p>
-            <a:pPr algn="ctr"/>
-          </a:p>
-        </p:txBody>
-      </p:sp>
-      <p:sp>
-        <p:nvSpPr>
-          <p:cNvPr id="20" name="TextBox 19"/>
-          <p:cNvSpPr txBox="1"/>
-          <p:nvPr/>
-        </p:nvSpPr>
-        <p:spPr>
-          <a:xfrm>
-            <a:off x="502920" y="3675887"/>
-            <a:ext cx="7242048" cy="274320"/>
-          </a:xfrm>
-          <a:prstGeom prst="rect">
-            <a:avLst/>
-          </a:prstGeom>
-          <a:noFill/>
-        </p:spPr>
-        <p:txBody>
-          <a:bodyPr wrap="square" anchor="t" lIns="25400" rIns="25400" tIns="12700" bIns="12700">
-            <a:spAutoFit/>
-          </a:bodyPr>
-          <a:lstStyle/>
-          <a:p>
-            <a:pPr algn="ctr">
-              <a:lnSpc>
-                <a:spcPct val="100000"/>
-              </a:lnSpc>
-            </a:pPr>
-            <a:r>
-              <a:rPr sz="1200" b="0">
-                <a:solidFill>
-                  <a:srgbClr val="D29922"/>
-                </a:solidFill>
-                <a:latin typeface="Calibri"/>
-              </a:rPr>
-              <a:t>↻  CEGAR — refine the spec &amp; re-check until the verdict is solid</a:t>
-            </a:r>
-          </a:p>
-        </p:txBody>
-      </p:sp>
-      <p:sp>
-        <p:nvSpPr>
-          <p:cNvPr id="21" name="TextBox 20"/>
-          <p:cNvSpPr txBox="1"/>
-          <p:nvPr/>
-        </p:nvSpPr>
-        <p:spPr>
-          <a:xfrm>
-            <a:off x="502920" y="4224528"/>
-            <a:ext cx="7589520" cy="365760"/>
-          </a:xfrm>
-          <a:prstGeom prst="rect">
-            <a:avLst/>
-          </a:prstGeom>
-          <a:noFill/>
-        </p:spPr>
-        <p:txBody>
-          <a:bodyPr wrap="square" anchor="t" lIns="25400" rIns="25400" tIns="12700" bIns="12700">
-            <a:spAutoFit/>
-          </a:bodyPr>
-          <a:lstStyle/>
-          <a:p>
-            <a:pPr algn="l">
-              <a:lnSpc>
-                <a:spcPct val="100000"/>
-              </a:lnSpc>
-            </a:pPr>
-            <a:r>
-              <a:rPr sz="1400" b="1">
-                <a:solidFill>
-                  <a:srgbClr val="E6EDF3"/>
-                </a:solidFill>
-                <a:latin typeface="Calibri"/>
-              </a:rPr>
-              <a:t>You can’t check it part-by-part — </a:t>
-            </a:r>
-            <a:r>
-              <a:rPr sz="1400" b="0">
-                <a:solidFill>
-                  <a:srgbClr val="8B949E"/>
-                </a:solidFill>
-                <a:latin typeface="Calibri"/>
-              </a:rPr>
-              <a:t>the bug threads through the composition:</a:t>
-            </a:r>
-          </a:p>
-        </p:txBody>
-      </p:sp>
-      <p:sp>
-        <p:nvSpPr>
-          <p:cNvPr id="22" name="Rounded Rectangle 21"/>
-          <p:cNvSpPr/>
-          <p:nvPr/>
-        </p:nvSpPr>
-        <p:spPr>
-          <a:xfrm>
-            <a:off x="502920" y="4608576"/>
-            <a:ext cx="1330452" cy="384048"/>
-          </a:xfrm>
-          <a:prstGeom prst="roundRect">
-            <a:avLst/>
-          </a:prstGeom>
-          <a:solidFill>
-            <a:srgbClr val="161B22"/>
-          </a:solidFill>
-          <a:ln w="19050">
-            <a:solidFill>
-              <a:srgbClr val="30363D"/>
-            </a:solidFill>
-          </a:ln>
-          <a:effectLst/>
-        </p:spPr>
-        <p:style>
-          <a:lnRef idx="1">
-            <a:schemeClr val="accent1"/>
-          </a:lnRef>
-          <a:fillRef idx="3">
-            <a:schemeClr val="accent1"/>
-          </a:fillRef>
-          <a:effectRef idx="2">
-            <a:schemeClr val="accent1"/>
-          </a:effectRef>
-          <a:fontRef idx="minor">
-            <a:schemeClr val="lt1"/>
-          </a:fontRef>
-        </p:style>
-        <p:txBody>
-          <a:bodyPr rtlCol="0" anchor="ctr"/>
-          <a:lstStyle/>
-          <a:p>
-            <a:pPr algn="ctr"/>
-          </a:p>
-        </p:txBody>
-      </p:sp>
-      <p:sp>
-        <p:nvSpPr>
-          <p:cNvPr id="23" name="TextBox 22"/>
-          <p:cNvSpPr txBox="1"/>
-          <p:nvPr/>
-        </p:nvSpPr>
-        <p:spPr>
-          <a:xfrm>
-            <a:off x="502920" y="4608576"/>
-            <a:ext cx="1330452" cy="384048"/>
-          </a:xfrm>
-          <a:prstGeom prst="rect">
-            <a:avLst/>
-          </a:prstGeom>
-          <a:noFill/>
-        </p:spPr>
-        <p:txBody>
-          <a:bodyPr wrap="square" anchor="ctr" lIns="25400" rIns="25400" tIns="12700" bIns="12700">
-            <a:spAutoFit/>
-          </a:bodyPr>
-          <a:lstStyle/>
-          <a:p>
-            <a:pPr algn="ctr">
-              <a:lnSpc>
-                <a:spcPct val="100000"/>
-              </a:lnSpc>
-            </a:pPr>
-            <a:r>
-              <a:rPr sz="1250" b="1">
-                <a:solidFill>
-                  <a:srgbClr val="E6EDF3"/>
-                </a:solidFill>
-                <a:latin typeface="Consolas"/>
-              </a:rPr>
-              <a:t>parse_chunk</a:t>
-            </a:r>
-          </a:p>
-        </p:txBody>
-      </p:sp>
-      <p:sp>
-        <p:nvSpPr>
-          <p:cNvPr id="24" name="TextBox 23"/>
-          <p:cNvSpPr txBox="1"/>
-          <p:nvPr/>
-        </p:nvSpPr>
-        <p:spPr>
-          <a:xfrm>
-            <a:off x="1833372" y="4608576"/>
-            <a:ext cx="310896" cy="384048"/>
-          </a:xfrm>
-          <a:prstGeom prst="rect">
-            <a:avLst/>
-          </a:prstGeom>
-          <a:noFill/>
-        </p:spPr>
-        <p:txBody>
-          <a:bodyPr wrap="square" anchor="ctr" lIns="25400" rIns="25400" tIns="12700" bIns="12700">
-            <a:spAutoFit/>
-          </a:bodyPr>
-          <a:lstStyle/>
-          <a:p>
-            <a:pPr algn="ctr">
-              <a:lnSpc>
-                <a:spcPct val="100000"/>
-              </a:lnSpc>
-            </a:pPr>
-            <a:r>
-              <a:rPr sz="1500" b="1">
-                <a:solidFill>
-                  <a:srgbClr val="8B949E"/>
-                </a:solidFill>
-                <a:latin typeface="Calibri"/>
-              </a:rPr>
-              <a:t>→</a:t>
-            </a:r>
-          </a:p>
-        </p:txBody>
-      </p:sp>
-      <p:sp>
-        <p:nvSpPr>
-          <p:cNvPr id="25" name="Rounded Rectangle 24"/>
-          <p:cNvSpPr/>
-          <p:nvPr/>
-        </p:nvSpPr>
-        <p:spPr>
-          <a:xfrm>
-            <a:off x="2144268" y="4608576"/>
-            <a:ext cx="1042415" cy="384048"/>
-          </a:xfrm>
-          <a:prstGeom prst="roundRect">
-            <a:avLst/>
-          </a:prstGeom>
-          <a:solidFill>
-            <a:srgbClr val="161B22"/>
-          </a:solidFill>
-          <a:ln w="19050">
-            <a:solidFill>
-              <a:srgbClr val="30363D"/>
-            </a:solidFill>
-          </a:ln>
-          <a:effectLst/>
-        </p:spPr>
-        <p:style>
-          <a:lnRef idx="1">
-            <a:schemeClr val="accent1"/>
-          </a:lnRef>
-          <a:fillRef idx="3">
-            <a:schemeClr val="accent1"/>
-          </a:fillRef>
-          <a:effectRef idx="2">
-            <a:schemeClr val="accent1"/>
-          </a:effectRef>
-          <a:fontRef idx="minor">
-            <a:schemeClr val="lt1"/>
-          </a:fontRef>
-        </p:style>
-        <p:txBody>
-          <a:bodyPr rtlCol="0" anchor="ctr"/>
-          <a:lstStyle/>
-          <a:p>
-            <a:pPr algn="ctr"/>
-          </a:p>
-        </p:txBody>
-      </p:sp>
-      <p:sp>
-        <p:nvSpPr>
-          <p:cNvPr id="26" name="TextBox 25"/>
-          <p:cNvSpPr txBox="1"/>
-          <p:nvPr/>
-        </p:nvSpPr>
-        <p:spPr>
-          <a:xfrm>
-            <a:off x="2144268" y="4608576"/>
-            <a:ext cx="1042415" cy="384048"/>
-          </a:xfrm>
-          <a:prstGeom prst="rect">
-            <a:avLst/>
-          </a:prstGeom>
-          <a:noFill/>
-        </p:spPr>
-        <p:txBody>
-          <a:bodyPr wrap="square" anchor="ctr" lIns="25400" rIns="25400" tIns="12700" bIns="12700">
-            <a:spAutoFit/>
-          </a:bodyPr>
-          <a:lstStyle/>
-          <a:p>
-            <a:pPr algn="ctr">
-              <a:lnSpc>
-                <a:spcPct val="100000"/>
-              </a:lnSpc>
-            </a:pPr>
-            <a:r>
-              <a:rPr sz="1250" b="1">
-                <a:solidFill>
-                  <a:srgbClr val="E6EDF3"/>
-                </a:solidFill>
-                <a:latin typeface="Consolas"/>
-              </a:rPr>
-              <a:t>read_tag</a:t>
-            </a:r>
-          </a:p>
-        </p:txBody>
-      </p:sp>
-      <p:sp>
-        <p:nvSpPr>
-          <p:cNvPr id="27" name="TextBox 26"/>
-          <p:cNvSpPr txBox="1"/>
-          <p:nvPr/>
-        </p:nvSpPr>
-        <p:spPr>
-          <a:xfrm>
-            <a:off x="3186683" y="4608576"/>
-            <a:ext cx="310896" cy="384048"/>
-          </a:xfrm>
-          <a:prstGeom prst="rect">
-            <a:avLst/>
-          </a:prstGeom>
-          <a:noFill/>
-        </p:spPr>
-        <p:txBody>
-          <a:bodyPr wrap="square" anchor="ctr" lIns="25400" rIns="25400" tIns="12700" bIns="12700">
-            <a:spAutoFit/>
-          </a:bodyPr>
-          <a:lstStyle/>
-          <a:p>
-            <a:pPr algn="ctr">
-              <a:lnSpc>
-                <a:spcPct val="100000"/>
-              </a:lnSpc>
-            </a:pPr>
-            <a:r>
-              <a:rPr sz="1500" b="1">
-                <a:solidFill>
-                  <a:srgbClr val="8B949E"/>
-                </a:solidFill>
-                <a:latin typeface="Calibri"/>
-              </a:rPr>
-              <a:t>→</a:t>
-            </a:r>
-          </a:p>
-        </p:txBody>
-      </p:sp>
-      <p:sp>
-        <p:nvSpPr>
-          <p:cNvPr id="28" name="Rounded Rectangle 27"/>
-          <p:cNvSpPr/>
-          <p:nvPr/>
-        </p:nvSpPr>
-        <p:spPr>
-          <a:xfrm>
-            <a:off x="3497579" y="4608576"/>
-            <a:ext cx="1042415" cy="384048"/>
-          </a:xfrm>
-          <a:prstGeom prst="roundRect">
-            <a:avLst/>
-          </a:prstGeom>
-          <a:solidFill>
-            <a:srgbClr val="161B22"/>
-          </a:solidFill>
-          <a:ln w="19050">
-            <a:solidFill>
-              <a:srgbClr val="F85149"/>
-            </a:solidFill>
-          </a:ln>
-          <a:effectLst/>
-        </p:spPr>
-        <p:style>
-          <a:lnRef idx="1">
-            <a:schemeClr val="accent1"/>
-          </a:lnRef>
-          <a:fillRef idx="3">
-            <a:schemeClr val="accent1"/>
-          </a:fillRef>
-          <a:effectRef idx="2">
-            <a:schemeClr val="accent1"/>
-          </a:effectRef>
-          <a:fontRef idx="minor">
-            <a:schemeClr val="lt1"/>
-          </a:fontRef>
-        </p:style>
-        <p:txBody>
-          <a:bodyPr rtlCol="0" anchor="ctr"/>
-          <a:lstStyle/>
-          <a:p>
-            <a:pPr algn="ctr"/>
-          </a:p>
-        </p:txBody>
-      </p:sp>
-      <p:sp>
-        <p:nvSpPr>
-          <p:cNvPr id="29" name="TextBox 28"/>
-          <p:cNvSpPr txBox="1"/>
-          <p:nvPr/>
-        </p:nvSpPr>
-        <p:spPr>
-          <a:xfrm>
-            <a:off x="3497579" y="4608576"/>
-            <a:ext cx="1042415" cy="384048"/>
-          </a:xfrm>
-          <a:prstGeom prst="rect">
-            <a:avLst/>
-          </a:prstGeom>
-          <a:noFill/>
-        </p:spPr>
-        <p:txBody>
-          <a:bodyPr wrap="square" anchor="ctr" lIns="25400" rIns="25400" tIns="12700" bIns="12700">
-            <a:spAutoFit/>
-          </a:bodyPr>
-          <a:lstStyle/>
-          <a:p>
-            <a:pPr algn="ctr">
-              <a:lnSpc>
-                <a:spcPct val="100000"/>
-              </a:lnSpc>
-            </a:pPr>
-            <a:r>
-              <a:rPr sz="1250" b="1">
-                <a:solidFill>
-                  <a:srgbClr val="F85149"/>
-                </a:solidFill>
-                <a:latin typeface="Consolas"/>
-              </a:rPr>
-              <a:t>buf[idx]</a:t>
-            </a:r>
-          </a:p>
-        </p:txBody>
-      </p:sp>
-      <p:sp>
-        <p:nvSpPr>
-          <p:cNvPr id="30" name="TextBox 29"/>
-          <p:cNvSpPr txBox="1"/>
-          <p:nvPr/>
-        </p:nvSpPr>
-        <p:spPr>
-          <a:xfrm>
-            <a:off x="502920" y="5120640"/>
-            <a:ext cx="7589520" cy="365760"/>
-          </a:xfrm>
-          <a:prstGeom prst="rect">
-            <a:avLst/>
-          </a:prstGeom>
-          <a:noFill/>
-        </p:spPr>
-        <p:txBody>
-          <a:bodyPr wrap="square" anchor="t" lIns="25400" rIns="25400" tIns="12700" bIns="12700">
-            <a:spAutoFit/>
-          </a:bodyPr>
-          <a:lstStyle/>
-          <a:p>
-            <a:pPr algn="l">
-              <a:lnSpc>
-                <a:spcPct val="100000"/>
-              </a:lnSpc>
-            </a:pPr>
-            <a:r>
-              <a:rPr sz="1150" b="0">
-                <a:solidFill>
-                  <a:srgbClr val="8B949E"/>
-                </a:solidFill>
-                <a:latin typeface="Consolas"/>
-              </a:rPr>
-              <a:t>spec </a:t>
-            </a:r>
-            <a:r>
-              <a:rPr sz="1150" b="1">
-                <a:solidFill>
-                  <a:srgbClr val="E6EDF3"/>
-                </a:solidFill>
-                <a:latin typeface="Consolas"/>
-              </a:rPr>
-              <a:t>idx &lt; len</a:t>
-            </a:r>
-            <a:r>
-              <a:rPr sz="1150" b="0">
-                <a:solidFill>
-                  <a:srgbClr val="8B949E"/>
-                </a:solidFill>
-                <a:latin typeface="Consolas"/>
-              </a:rPr>
-              <a:t> violated  ·  </a:t>
-            </a:r>
-            <a:r>
-              <a:rPr sz="1150" b="1">
-                <a:solidFill>
-                  <a:srgbClr val="E6EDF3"/>
-                </a:solidFill>
-                <a:latin typeface="Consolas"/>
-              </a:rPr>
-              <a:t>len=8, idx=12</a:t>
-            </a:r>
-            <a:r>
-              <a:rPr sz="1150" b="0">
-                <a:solidFill>
-                  <a:srgbClr val="8B949E"/>
-                </a:solidFill>
-                <a:latin typeface="Consolas"/>
-              </a:rPr>
-              <a:t>  ·  replayed under ASan → </a:t>
-            </a:r>
-            <a:r>
-              <a:rPr sz="1150" b="1">
-                <a:solidFill>
-                  <a:srgbClr val="F85149"/>
-                </a:solidFill>
-                <a:latin typeface="Consolas"/>
-              </a:rPr>
-              <a:t>SEGV</a:t>
-            </a:r>
-          </a:p>
-        </p:txBody>
-      </p:sp>
-      <p:sp>
-        <p:nvSpPr>
-          <p:cNvPr id="31" name="Rounded Rectangle 30"/>
-          <p:cNvSpPr/>
-          <p:nvPr/>
-        </p:nvSpPr>
-        <p:spPr>
-          <a:xfrm>
-            <a:off x="502920" y="5870448"/>
-            <a:ext cx="1933041" cy="384048"/>
-          </a:xfrm>
-          <a:prstGeom prst="roundRect">
-            <a:avLst/>
-          </a:prstGeom>
-          <a:solidFill>
-            <a:srgbClr val="161B22"/>
+            <a:srgbClr val="FFFFFF"/>
           </a:solidFill>
           <a:ln w="12700">
             <a:solidFill>
@@ -4475,60 +3444,40 @@
           </a:p>
         </p:txBody>
       </p:sp>
-      <p:sp>
-        <p:nvSpPr>
-          <p:cNvPr id="32" name="Oval 31"/>
-          <p:cNvSpPr/>
+      <p:pic>
+        <p:nvPicPr>
+          <p:cNvPr id="9" name="Picture 8" descr="_qr.png"/>
+          <p:cNvPicPr>
+            <a:picLocks noChangeAspect="1"/>
+          </p:cNvPicPr>
           <p:nvPr/>
-        </p:nvSpPr>
+        </p:nvPicPr>
+        <p:blipFill>
+          <a:blip r:embed="rId2"/>
+          <a:stretch>
+            <a:fillRect/>
+          </a:stretch>
+        </p:blipFill>
         <p:spPr>
           <a:xfrm>
-            <a:off x="630936" y="6007608"/>
-            <a:ext cx="109728" cy="109728"/>
+            <a:off x="548640" y="5074920"/>
+            <a:ext cx="1417320" cy="1417320"/>
           </a:xfrm>
-          <a:prstGeom prst="ellipse">
+          <a:prstGeom prst="rect">
             <a:avLst/>
           </a:prstGeom>
-          <a:solidFill>
-            <a:srgbClr val="3FB950"/>
-          </a:solidFill>
-          <a:ln>
-            <a:noFill/>
-          </a:ln>
-          <a:effectLst/>
         </p:spPr>
-        <p:style>
-          <a:lnRef idx="1">
-            <a:schemeClr val="accent1"/>
-          </a:lnRef>
-          <a:fillRef idx="3">
-            <a:schemeClr val="accent1"/>
-          </a:fillRef>
-          <a:effectRef idx="2">
-            <a:schemeClr val="accent1"/>
-          </a:effectRef>
-          <a:fontRef idx="minor">
-            <a:schemeClr val="lt1"/>
-          </a:fontRef>
-        </p:style>
-        <p:txBody>
-          <a:bodyPr rtlCol="0" anchor="ctr"/>
-          <a:lstStyle/>
-          <a:p>
-            <a:pPr algn="ctr"/>
-          </a:p>
-        </p:txBody>
-      </p:sp>
-      <p:sp>
-        <p:nvSpPr>
-          <p:cNvPr id="33" name="TextBox 32"/>
+      </p:pic>
+      <p:sp>
+        <p:nvSpPr>
+          <p:cNvPr id="10" name="TextBox 9"/>
           <p:cNvSpPr txBox="1"/>
           <p:nvPr/>
         </p:nvSpPr>
         <p:spPr>
           <a:xfrm>
-            <a:off x="813816" y="5870448"/>
-            <a:ext cx="1567281" cy="384048"/>
+            <a:off x="2176272" y="5111496"/>
+            <a:ext cx="3611880" cy="274320"/>
           </a:xfrm>
           <a:prstGeom prst="rect">
             <a:avLst/>
@@ -4536,7 +3485,7 @@
           <a:noFill/>
         </p:spPr>
         <p:txBody>
-          <a:bodyPr wrap="square" anchor="ctr" lIns="25400" rIns="25400" tIns="12700" bIns="12700">
+          <a:bodyPr wrap="square" anchor="t" lIns="25400" rIns="25400" tIns="12700" bIns="12700">
             <a:spAutoFit/>
           </a:bodyPr>
           <a:lstStyle/>
@@ -4547,35 +3496,161 @@
               </a:lnSpc>
             </a:pPr>
             <a:r>
-              <a:rPr sz="1100" b="0">
+              <a:rPr sz="1050" b="1">
+                <a:solidFill>
+                  <a:srgbClr val="8B949E"/>
+                </a:solidFill>
+                <a:latin typeface="Consolas"/>
+              </a:rPr>
+              <a:t>EXPLORE THE PROJECT</a:t>
+            </a:r>
+          </a:p>
+        </p:txBody>
+      </p:sp>
+      <p:sp>
+        <p:nvSpPr>
+          <p:cNvPr id="11" name="TextBox 10"/>
+          <p:cNvSpPr txBox="1"/>
+          <p:nvPr/>
+        </p:nvSpPr>
+        <p:spPr>
+          <a:xfrm>
+            <a:off x="2176272" y="5385816"/>
+            <a:ext cx="3611880" cy="365760"/>
+          </a:xfrm>
+          <a:prstGeom prst="rect">
+            <a:avLst/>
+          </a:prstGeom>
+          <a:noFill/>
+        </p:spPr>
+        <p:txBody>
+          <a:bodyPr wrap="square" anchor="t" lIns="25400" rIns="25400" tIns="12700" bIns="12700">
+            <a:spAutoFit/>
+          </a:bodyPr>
+          <a:lstStyle/>
+          <a:p>
+            <a:pPr algn="l">
+              <a:lnSpc>
+                <a:spcPct val="100000"/>
+              </a:lnSpc>
+            </a:pPr>
+            <a:r>
+              <a:rPr sz="1450" b="1">
+                <a:solidFill>
+                  <a:srgbClr val="58A6FF"/>
+                </a:solidFill>
+                <a:latin typeface="Consolas"/>
+              </a:rPr>
+              <a:t>github.com/agentic-prover/aprover</a:t>
+            </a:r>
+          </a:p>
+        </p:txBody>
+      </p:sp>
+      <p:sp>
+        <p:nvSpPr>
+          <p:cNvPr id="12" name="TextBox 11"/>
+          <p:cNvSpPr txBox="1"/>
+          <p:nvPr/>
+        </p:nvSpPr>
+        <p:spPr>
+          <a:xfrm>
+            <a:off x="2176272" y="5788152"/>
+            <a:ext cx="3611880" cy="457200"/>
+          </a:xfrm>
+          <a:prstGeom prst="rect">
+            <a:avLst/>
+          </a:prstGeom>
+          <a:noFill/>
+        </p:spPr>
+        <p:txBody>
+          <a:bodyPr wrap="square" anchor="t" lIns="25400" rIns="25400" tIns="12700" bIns="12700">
+            <a:spAutoFit/>
+          </a:bodyPr>
+          <a:lstStyle/>
+          <a:p>
+            <a:pPr algn="l">
+              <a:lnSpc>
+                <a:spcPct val="105000"/>
+              </a:lnSpc>
+            </a:pPr>
+            <a:r>
+              <a:rPr sz="1150" b="0">
+                <a:solidFill>
+                  <a:srgbClr val="8B949E"/>
+                </a:solidFill>
+                <a:latin typeface="Calibri"/>
+              </a:rPr>
+              <a:t>Paper · </a:t>
+            </a:r>
+            <a:r>
+              <a:rPr sz="1150" b="0">
                 <a:solidFill>
                   <a:srgbClr val="E6EDF3"/>
                 </a:solidFill>
+                <a:latin typeface="Calibri"/>
+              </a:rPr>
+              <a:t>Agentic Model Checking — arXiv:2605.21434</a:t>
+            </a:r>
+          </a:p>
+        </p:txBody>
+      </p:sp>
+      <p:sp>
+        <p:nvSpPr>
+          <p:cNvPr id="13" name="TextBox 12"/>
+          <p:cNvSpPr txBox="1"/>
+          <p:nvPr/>
+        </p:nvSpPr>
+        <p:spPr>
+          <a:xfrm>
+            <a:off x="2176272" y="6245352"/>
+            <a:ext cx="3611880" cy="274320"/>
+          </a:xfrm>
+          <a:prstGeom prst="rect">
+            <a:avLst/>
+          </a:prstGeom>
+          <a:noFill/>
+        </p:spPr>
+        <p:txBody>
+          <a:bodyPr wrap="square" anchor="t" lIns="25400" rIns="25400" tIns="12700" bIns="12700">
+            <a:spAutoFit/>
+          </a:bodyPr>
+          <a:lstStyle/>
+          <a:p>
+            <a:pPr algn="l">
+              <a:lnSpc>
+                <a:spcPct val="100000"/>
+              </a:lnSpc>
+            </a:pPr>
+            <a:r>
+              <a:rPr sz="1050" b="0">
+                <a:solidFill>
+                  <a:srgbClr val="8B949E"/>
+                </a:solidFill>
                 <a:latin typeface="Consolas"/>
               </a:rPr>
-              <a:t>confirmed_dynamic</a:t>
-            </a:r>
-          </a:p>
-        </p:txBody>
-      </p:sp>
-      <p:sp>
-        <p:nvSpPr>
-          <p:cNvPr id="34" name="Rounded Rectangle 33"/>
+              <a:t>↗ scan to open</a:t>
+            </a:r>
+          </a:p>
+        </p:txBody>
+      </p:sp>
+      <p:sp>
+        <p:nvSpPr>
+          <p:cNvPr id="14" name="Rounded Rectangle 13"/>
           <p:cNvSpPr/>
           <p:nvPr/>
         </p:nvSpPr>
         <p:spPr>
           <a:xfrm>
-            <a:off x="2600553" y="5870448"/>
-            <a:ext cx="2353665" cy="384048"/>
+            <a:off x="5989320" y="2084832"/>
+            <a:ext cx="5779007" cy="3599307"/>
           </a:xfrm>
           <a:prstGeom prst="roundRect">
             <a:avLst/>
           </a:prstGeom>
           <a:solidFill>
-            <a:srgbClr val="161B22"/>
+            <a:srgbClr val="05070B"/>
           </a:solidFill>
-          <a:ln w="12700">
+          <a:ln w="17780">
             <a:solidFill>
               <a:srgbClr val="30363D"/>
             </a:solidFill>
@@ -4606,272 +3681,14 @@
       </p:sp>
       <p:sp>
         <p:nvSpPr>
-          <p:cNvPr id="35" name="Oval 34"/>
+          <p:cNvPr id="15" name="Rounded Rectangle 14"/>
           <p:cNvSpPr/>
           <p:nvPr/>
         </p:nvSpPr>
         <p:spPr>
           <a:xfrm>
-            <a:off x="2728569" y="6007608"/>
-            <a:ext cx="109728" cy="109728"/>
-          </a:xfrm>
-          <a:prstGeom prst="ellipse">
-            <a:avLst/>
-          </a:prstGeom>
-          <a:solidFill>
-            <a:srgbClr val="58A6FF"/>
-          </a:solidFill>
-          <a:ln>
-            <a:noFill/>
-          </a:ln>
-          <a:effectLst/>
-        </p:spPr>
-        <p:style>
-          <a:lnRef idx="1">
-            <a:schemeClr val="accent1"/>
-          </a:lnRef>
-          <a:fillRef idx="3">
-            <a:schemeClr val="accent1"/>
-          </a:fillRef>
-          <a:effectRef idx="2">
-            <a:schemeClr val="accent1"/>
-          </a:effectRef>
-          <a:fontRef idx="minor">
-            <a:schemeClr val="lt1"/>
-          </a:fontRef>
-        </p:style>
-        <p:txBody>
-          <a:bodyPr rtlCol="0" anchor="ctr"/>
-          <a:lstStyle/>
-          <a:p>
-            <a:pPr algn="ctr"/>
-          </a:p>
-        </p:txBody>
-      </p:sp>
-      <p:sp>
-        <p:nvSpPr>
-          <p:cNvPr id="36" name="TextBox 35"/>
-          <p:cNvSpPr txBox="1"/>
-          <p:nvPr/>
-        </p:nvSpPr>
-        <p:spPr>
-          <a:xfrm>
-            <a:off x="2911449" y="5870448"/>
-            <a:ext cx="1987905" cy="384048"/>
-          </a:xfrm>
-          <a:prstGeom prst="rect">
-            <a:avLst/>
-          </a:prstGeom>
-          <a:noFill/>
-        </p:spPr>
-        <p:txBody>
-          <a:bodyPr wrap="square" anchor="ctr" lIns="25400" rIns="25400" tIns="12700" bIns="12700">
-            <a:spAutoFit/>
-          </a:bodyPr>
-          <a:lstStyle/>
-          <a:p>
-            <a:pPr algn="l">
-              <a:lnSpc>
-                <a:spcPct val="100000"/>
-              </a:lnSpc>
-            </a:pPr>
-            <a:r>
-              <a:rPr sz="1100" b="0">
-                <a:solidFill>
-                  <a:srgbClr val="E6EDF3"/>
-                </a:solidFill>
-                <a:latin typeface="Consolas"/>
-              </a:rPr>
-              <a:t>confirmed_system_entry</a:t>
-            </a:r>
-          </a:p>
-        </p:txBody>
-      </p:sp>
-      <p:sp>
-        <p:nvSpPr>
-          <p:cNvPr id="37" name="Rounded Rectangle 36"/>
-          <p:cNvSpPr/>
-          <p:nvPr/>
-        </p:nvSpPr>
-        <p:spPr>
-          <a:xfrm>
-            <a:off x="5118811" y="5870448"/>
-            <a:ext cx="1596542" cy="384048"/>
-          </a:xfrm>
-          <a:prstGeom prst="roundRect">
-            <a:avLst/>
-          </a:prstGeom>
-          <a:solidFill>
-            <a:srgbClr val="161B22"/>
-          </a:solidFill>
-          <a:ln w="12700">
-            <a:solidFill>
-              <a:srgbClr val="30363D"/>
-            </a:solidFill>
-          </a:ln>
-          <a:effectLst/>
-        </p:spPr>
-        <p:style>
-          <a:lnRef idx="1">
-            <a:schemeClr val="accent1"/>
-          </a:lnRef>
-          <a:fillRef idx="3">
-            <a:schemeClr val="accent1"/>
-          </a:fillRef>
-          <a:effectRef idx="2">
-            <a:schemeClr val="accent1"/>
-          </a:effectRef>
-          <a:fontRef idx="minor">
-            <a:schemeClr val="lt1"/>
-          </a:fontRef>
-        </p:style>
-        <p:txBody>
-          <a:bodyPr rtlCol="0" anchor="ctr"/>
-          <a:lstStyle/>
-          <a:p>
-            <a:pPr algn="ctr"/>
-          </a:p>
-        </p:txBody>
-      </p:sp>
-      <p:sp>
-        <p:nvSpPr>
-          <p:cNvPr id="38" name="Oval 37"/>
-          <p:cNvSpPr/>
-          <p:nvPr/>
-        </p:nvSpPr>
-        <p:spPr>
-          <a:xfrm>
-            <a:off x="5246827" y="6007608"/>
-            <a:ext cx="109728" cy="109728"/>
-          </a:xfrm>
-          <a:prstGeom prst="ellipse">
-            <a:avLst/>
-          </a:prstGeom>
-          <a:solidFill>
-            <a:srgbClr val="888888"/>
-          </a:solidFill>
-          <a:ln>
-            <a:noFill/>
-          </a:ln>
-          <a:effectLst/>
-        </p:spPr>
-        <p:style>
-          <a:lnRef idx="1">
-            <a:schemeClr val="accent1"/>
-          </a:lnRef>
-          <a:fillRef idx="3">
-            <a:schemeClr val="accent1"/>
-          </a:fillRef>
-          <a:effectRef idx="2">
-            <a:schemeClr val="accent1"/>
-          </a:effectRef>
-          <a:fontRef idx="minor">
-            <a:schemeClr val="lt1"/>
-          </a:fontRef>
-        </p:style>
-        <p:txBody>
-          <a:bodyPr rtlCol="0" anchor="ctr"/>
-          <a:lstStyle/>
-          <a:p>
-            <a:pPr algn="ctr"/>
-          </a:p>
-        </p:txBody>
-      </p:sp>
-      <p:sp>
-        <p:nvSpPr>
-          <p:cNvPr id="39" name="TextBox 38"/>
-          <p:cNvSpPr txBox="1"/>
-          <p:nvPr/>
-        </p:nvSpPr>
-        <p:spPr>
-          <a:xfrm>
-            <a:off x="5429707" y="5870448"/>
-            <a:ext cx="1230782" cy="384048"/>
-          </a:xfrm>
-          <a:prstGeom prst="rect">
-            <a:avLst/>
-          </a:prstGeom>
-          <a:noFill/>
-        </p:spPr>
-        <p:txBody>
-          <a:bodyPr wrap="square" anchor="ctr" lIns="25400" rIns="25400" tIns="12700" bIns="12700">
-            <a:spAutoFit/>
-          </a:bodyPr>
-          <a:lstStyle/>
-          <a:p>
-            <a:pPr algn="l">
-              <a:lnSpc>
-                <a:spcPct val="100000"/>
-              </a:lnSpc>
-            </a:pPr>
-            <a:r>
-              <a:rPr sz="1100" b="0">
-                <a:solidFill>
-                  <a:srgbClr val="E6EDF3"/>
-                </a:solidFill>
-                <a:latin typeface="Consolas"/>
-              </a:rPr>
-              <a:t>confirmed_bmc</a:t>
-            </a:r>
-          </a:p>
-        </p:txBody>
-      </p:sp>
-      <p:sp>
-        <p:nvSpPr>
-          <p:cNvPr id="40" name="Rounded Rectangle 39"/>
-          <p:cNvSpPr/>
-          <p:nvPr/>
-        </p:nvSpPr>
-        <p:spPr>
-          <a:xfrm>
-            <a:off x="8220456" y="2340864"/>
-            <a:ext cx="3520440" cy="2339149"/>
-          </a:xfrm>
-          <a:prstGeom prst="roundRect">
-            <a:avLst/>
-          </a:prstGeom>
-          <a:solidFill>
-            <a:srgbClr val="05070B"/>
-          </a:solidFill>
-          <a:ln w="15875">
-            <a:solidFill>
-              <a:srgbClr val="30363D"/>
-            </a:solidFill>
-          </a:ln>
-          <a:effectLst/>
-        </p:spPr>
-        <p:style>
-          <a:lnRef idx="1">
-            <a:schemeClr val="accent1"/>
-          </a:lnRef>
-          <a:fillRef idx="3">
-            <a:schemeClr val="accent1"/>
-          </a:fillRef>
-          <a:effectRef idx="2">
-            <a:schemeClr val="accent1"/>
-          </a:effectRef>
-          <a:fontRef idx="minor">
-            <a:schemeClr val="lt1"/>
-          </a:fontRef>
-        </p:style>
-        <p:txBody>
-          <a:bodyPr rtlCol="0" anchor="ctr"/>
-          <a:lstStyle/>
-          <a:p>
-            <a:pPr algn="ctr"/>
-          </a:p>
-        </p:txBody>
-      </p:sp>
-      <p:sp>
-        <p:nvSpPr>
-          <p:cNvPr id="41" name="Rounded Rectangle 40"/>
-          <p:cNvSpPr/>
-          <p:nvPr/>
-        </p:nvSpPr>
-        <p:spPr>
-          <a:xfrm>
-            <a:off x="8275320" y="2395728"/>
-            <a:ext cx="3410712" cy="274320"/>
+            <a:off x="6053328" y="2148840"/>
+            <a:ext cx="5650992" cy="292608"/>
           </a:xfrm>
           <a:prstGeom prst="roundRect">
             <a:avLst/>
@@ -4908,14 +3725,14 @@
       </p:sp>
       <p:sp>
         <p:nvSpPr>
-          <p:cNvPr id="42" name="Oval 41"/>
+          <p:cNvPr id="16" name="Oval 15"/>
           <p:cNvSpPr/>
           <p:nvPr/>
         </p:nvSpPr>
         <p:spPr>
           <a:xfrm>
-            <a:off x="8403336" y="2487168"/>
-            <a:ext cx="91440" cy="91440"/>
+            <a:off x="6199632" y="2249424"/>
+            <a:ext cx="100584" cy="100584"/>
           </a:xfrm>
           <a:prstGeom prst="ellipse">
             <a:avLst/>
@@ -4952,14 +3769,14 @@
       </p:sp>
       <p:sp>
         <p:nvSpPr>
-          <p:cNvPr id="43" name="Oval 42"/>
+          <p:cNvPr id="17" name="Oval 16"/>
           <p:cNvSpPr/>
           <p:nvPr/>
         </p:nvSpPr>
         <p:spPr>
           <a:xfrm>
-            <a:off x="8567928" y="2487168"/>
-            <a:ext cx="91440" cy="91440"/>
+            <a:off x="6373368" y="2249424"/>
+            <a:ext cx="100584" cy="100584"/>
           </a:xfrm>
           <a:prstGeom prst="ellipse">
             <a:avLst/>
@@ -4996,14 +3813,14 @@
       </p:sp>
       <p:sp>
         <p:nvSpPr>
-          <p:cNvPr id="44" name="Oval 43"/>
+          <p:cNvPr id="18" name="Oval 17"/>
           <p:cNvSpPr/>
           <p:nvPr/>
         </p:nvSpPr>
         <p:spPr>
           <a:xfrm>
-            <a:off x="8732520" y="2487168"/>
-            <a:ext cx="91440" cy="91440"/>
+            <a:off x="6547104" y="2249424"/>
+            <a:ext cx="100584" cy="100584"/>
           </a:xfrm>
           <a:prstGeom prst="ellipse">
             <a:avLst/>
@@ -5040,14 +3857,14 @@
       </p:sp>
       <p:sp>
         <p:nvSpPr>
-          <p:cNvPr id="45" name="TextBox 44"/>
+          <p:cNvPr id="19" name="TextBox 18"/>
           <p:cNvSpPr txBox="1"/>
           <p:nvPr/>
         </p:nvSpPr>
         <p:spPr>
           <a:xfrm>
-            <a:off x="8951976" y="2395728"/>
-            <a:ext cx="2130552" cy="274320"/>
+            <a:off x="6766560" y="2148840"/>
+            <a:ext cx="4187952" cy="292608"/>
           </a:xfrm>
           <a:prstGeom prst="rect">
             <a:avLst/>
@@ -5066,27 +3883,27 @@
               </a:lnSpc>
             </a:pPr>
             <a:r>
-              <a:rPr sz="1000" b="0">
+              <a:rPr sz="1050" b="0">
                 <a:solidFill>
                   <a:srgbClr val="8B949E"/>
                 </a:solidFill>
                 <a:latin typeface="Consolas"/>
               </a:rPr>
-              <a:t>bmc-agent demo</a:t>
-            </a:r>
-          </a:p>
-        </p:txBody>
-      </p:sp>
-      <p:sp>
-        <p:nvSpPr>
-          <p:cNvPr id="46" name="TextBox 45"/>
+              <a:t>bmc-agent — verifying AI-generated software</a:t>
+            </a:r>
+          </a:p>
+        </p:txBody>
+      </p:sp>
+      <p:sp>
+        <p:nvSpPr>
+          <p:cNvPr id="20" name="TextBox 19"/>
           <p:cNvSpPr txBox="1"/>
           <p:nvPr/>
         </p:nvSpPr>
         <p:spPr>
           <a:xfrm>
-            <a:off x="10680192" y="2395728"/>
-            <a:ext cx="914400" cy="274320"/>
+            <a:off x="10607040" y="2148840"/>
+            <a:ext cx="1005840" cy="292608"/>
           </a:xfrm>
           <a:prstGeom prst="rect">
             <a:avLst/>
@@ -5105,7 +3922,7 @@
               </a:lnSpc>
             </a:pPr>
             <a:r>
-              <a:rPr sz="900" b="0">
+              <a:rPr sz="950" b="0">
                 <a:solidFill>
                   <a:srgbClr val="3FB950"/>
                 </a:solidFill>
@@ -5118,31 +3935,31 @@
       </p:sp>
       <p:pic>
         <p:nvPicPr>
-          <p:cNvPr id="47" name="bmc-agent-demo.mp4">
+          <p:cNvPr id="21" name="bmc-agent-demo.mp4">
             <a:hlinkClick r:id="" action="ppaction://media"/>
           </p:cNvPr>
           <p:cNvPicPr>
             <a:picLocks noChangeAspect="1"/>
           </p:cNvPicPr>
           <p:nvPr>
-            <a:videoFile r:link="rId3"/>
+            <a:videoFile r:link="rId4"/>
             <p:extLst>
               <p:ext uri="{DAA4B4D4-6D71-4841-9C94-3DE7FCFB9230}">
-                <p14:media xmlns:p14="http://schemas.microsoft.com/office/powerpoint/2010/main" r:embed="rId2"/>
+                <p14:media xmlns:p14="http://schemas.microsoft.com/office/powerpoint/2010/main" r:embed="rId3"/>
               </p:ext>
             </p:extLst>
           </p:nvPr>
         </p:nvPicPr>
         <p:blipFill>
-          <a:blip r:embed="rId4"/>
+          <a:blip r:embed="rId5"/>
           <a:stretch>
             <a:fillRect/>
           </a:stretch>
         </p:blipFill>
         <p:spPr>
           <a:xfrm>
-            <a:off x="8275320" y="2670048"/>
-            <a:ext cx="3410712" cy="1918525"/>
+            <a:off x="6053328" y="2441448"/>
+            <a:ext cx="5650992" cy="3178683"/>
           </a:xfrm>
           <a:prstGeom prst="rect">
             <a:avLst/>
@@ -5151,14 +3968,14 @@
       </p:pic>
       <p:sp>
         <p:nvSpPr>
-          <p:cNvPr id="48" name="TextBox 47"/>
+          <p:cNvPr id="22" name="TextBox 21"/>
           <p:cNvSpPr txBox="1"/>
           <p:nvPr/>
         </p:nvSpPr>
         <p:spPr>
           <a:xfrm>
-            <a:off x="8275320" y="4643437"/>
-            <a:ext cx="3410712" cy="274320"/>
+            <a:off x="6053328" y="5729859"/>
+            <a:ext cx="5650992" cy="274320"/>
           </a:xfrm>
           <a:prstGeom prst="rect">
             <a:avLst/>
@@ -5177,52 +3994,13 @@
               </a:lnSpc>
             </a:pPr>
             <a:r>
-              <a:rPr sz="1050" b="0">
+              <a:rPr sz="1100" b="0">
                 <a:solidFill>
                   <a:srgbClr val="5A6573"/>
                 </a:solidFill>
                 <a:latin typeface="Calibri"/>
               </a:rPr>
-              <a:t>▶ Embedded video — plays in slideshow</a:t>
-            </a:r>
-          </a:p>
-        </p:txBody>
-      </p:sp>
-      <p:sp>
-        <p:nvSpPr>
-          <p:cNvPr id="49" name="TextBox 48"/>
-          <p:cNvSpPr txBox="1"/>
-          <p:nvPr/>
-        </p:nvSpPr>
-        <p:spPr>
-          <a:xfrm>
-            <a:off x="8220456" y="5870448"/>
-            <a:ext cx="3520440" cy="384048"/>
-          </a:xfrm>
-          <a:prstGeom prst="rect">
-            <a:avLst/>
-          </a:prstGeom>
-          <a:noFill/>
-        </p:spPr>
-        <p:txBody>
-          <a:bodyPr wrap="square" anchor="ctr" lIns="25400" rIns="25400" tIns="12700" bIns="12700">
-            <a:spAutoFit/>
-          </a:bodyPr>
-          <a:lstStyle/>
-          <a:p>
-            <a:pPr algn="r">
-              <a:lnSpc>
-                <a:spcPct val="100000"/>
-              </a:lnSpc>
-            </a:pPr>
-            <a:r>
-              <a:rPr sz="1300" b="1">
-                <a:solidFill>
-                  <a:srgbClr val="E6EDF3"/>
-                </a:solidFill>
-                <a:latin typeface="Calibri"/>
-              </a:rPr>
-              <a:t>bugs confirmed, not guessed.</a:t>
+              <a:t>▶  embedded — plays in the slideshow   ·   the rest of the story is in the video</a:t>
             </a:r>
           </a:p>
         </p:txBody>
@@ -5245,7 +4023,7 @@
                   </p:stCondLst>
                 </p:cTn>
                 <p:tgtEl>
-                  <p:spTgt spid="47"/>
+                  <p:spTgt spid="21"/>
                 </p:tgtEl>
               </p:cMediaNode>
             </p:video>

</xml_diff>

<commit_message>
presentation: add confirmed-bug results (59 across 9 projects)
New animated Results scene in the deck + a stats strip in the PPTX, summarising
the embargo repo's confirmed (ASan-verified) memory-safety bugs:
- OSS-Fuzz (50/6): u-boot 32, gpac 10, libbej 4, libredwg 2, libheif 1, libarchive 1
- open-source (9/3): libmikmod 4, adplug 3, libmodplug 2
Bars grouped + color-coded; "embargoed, coordinated disclosure" footnote.
Re-recorded the 44s video (9 scenes) and rebuilt the PPTX.

NOTE: names embargoed/unreported projects — do NOT push to the public repo
without a disclosure decision (this is the content findings/oss-fuzz/ is
gitignored to keep private).

Co-Authored-By: Claude Opus 4.8 (1M context) <noreply@anthropic.com>
</commit_message>
<xml_diff>
--- a/presentation/agentic-prover.pptx
+++ b/presentation/agentic-prover.pptx
@@ -3963,7 +3963,7 @@
           <a:noFill/>
         </p:spPr>
         <p:txBody>
-          <a:bodyPr wrap="square" anchor="t" lIns="25400" rIns="25400" tIns="12700" bIns="12700">
+          <a:bodyPr wrap="square" anchor="ctr" lIns="25400" rIns="25400" tIns="12700" bIns="12700">
             <a:spAutoFit/>
           </a:bodyPr>
           <a:lstStyle/>
@@ -3974,13 +3974,166 @@
               </a:lnSpc>
             </a:pPr>
             <a:r>
-              <a:rPr sz="1100" b="0">
-                <a:solidFill>
-                  <a:srgbClr val="5A6573"/>
+              <a:rPr sz="1800" b="1">
+                <a:solidFill>
+                  <a:srgbClr val="3FB950"/>
                 </a:solidFill>
                 <a:latin typeface="Calibri"/>
               </a:rPr>
-              <a:t>▶  embedded — plays in the slideshow   ·   the rest of the story is in the video</a:t>
+              <a:t>59</a:t>
+            </a:r>
+            <a:r>
+              <a:rPr sz="1350" b="1">
+                <a:solidFill>
+                  <a:srgbClr val="E6EDF3"/>
+                </a:solidFill>
+                <a:latin typeface="Calibri"/>
+              </a:rPr>
+              <a:t>  confirmed memory-safety bugs</a:t>
+            </a:r>
+            <a:r>
+              <a:rPr sz="1100" b="0">
+                <a:solidFill>
+                  <a:srgbClr val="8B949E"/>
+                </a:solidFill>
+                <a:latin typeface="Calibri"/>
+              </a:rPr>
+              <a:t>   ·   every one ASan-verified</a:t>
+            </a:r>
+          </a:p>
+        </p:txBody>
+      </p:sp>
+      <p:sp>
+        <p:nvSpPr>
+          <p:cNvPr id="23" name="TextBox 22"/>
+          <p:cNvSpPr txBox="1"/>
+          <p:nvPr/>
+        </p:nvSpPr>
+        <p:spPr>
+          <a:xfrm>
+            <a:off x="6053328" y="6095619"/>
+            <a:ext cx="5650992" cy="201168"/>
+          </a:xfrm>
+          <a:prstGeom prst="rect">
+            <a:avLst/>
+          </a:prstGeom>
+          <a:noFill/>
+        </p:spPr>
+        <p:txBody>
+          <a:bodyPr wrap="square" anchor="t" lIns="25400" rIns="25400" tIns="12700" bIns="12700">
+            <a:spAutoFit/>
+          </a:bodyPr>
+          <a:lstStyle/>
+          <a:p>
+            <a:pPr algn="ctr">
+              <a:lnSpc>
+                <a:spcPct val="100000"/>
+              </a:lnSpc>
+            </a:pPr>
+            <a:r>
+              <a:rPr sz="950" b="1">
+                <a:solidFill>
+                  <a:srgbClr val="58A6FF"/>
+                </a:solidFill>
+                <a:latin typeface="Consolas"/>
+              </a:rPr>
+              <a:t>OSS-Fuzz 50   </a:t>
+            </a:r>
+            <a:r>
+              <a:rPr sz="950" b="0">
+                <a:solidFill>
+                  <a:srgbClr val="8B949E"/>
+                </a:solidFill>
+                <a:latin typeface="Consolas"/>
+              </a:rPr>
+              <a:t>u-boot 32 · gpac 10 · libbej 4 · libredwg 2 · libheif 1 · libarchive 1</a:t>
+            </a:r>
+          </a:p>
+        </p:txBody>
+      </p:sp>
+      <p:sp>
+        <p:nvSpPr>
+          <p:cNvPr id="24" name="TextBox 23"/>
+          <p:cNvSpPr txBox="1"/>
+          <p:nvPr/>
+        </p:nvSpPr>
+        <p:spPr>
+          <a:xfrm>
+            <a:off x="6053328" y="6315075"/>
+            <a:ext cx="5650992" cy="201168"/>
+          </a:xfrm>
+          <a:prstGeom prst="rect">
+            <a:avLst/>
+          </a:prstGeom>
+          <a:noFill/>
+        </p:spPr>
+        <p:txBody>
+          <a:bodyPr wrap="square" anchor="t" lIns="25400" rIns="25400" tIns="12700" bIns="12700">
+            <a:spAutoFit/>
+          </a:bodyPr>
+          <a:lstStyle/>
+          <a:p>
+            <a:pPr algn="ctr">
+              <a:lnSpc>
+                <a:spcPct val="100000"/>
+              </a:lnSpc>
+            </a:pPr>
+            <a:r>
+              <a:rPr sz="950" b="1">
+                <a:solidFill>
+                  <a:srgbClr val="A371F7"/>
+                </a:solidFill>
+                <a:latin typeface="Consolas"/>
+              </a:rPr>
+              <a:t>open-source 9   </a:t>
+            </a:r>
+            <a:r>
+              <a:rPr sz="950" b="0">
+                <a:solidFill>
+                  <a:srgbClr val="8B949E"/>
+                </a:solidFill>
+                <a:latin typeface="Consolas"/>
+              </a:rPr>
+              <a:t>libmikmod 4 · adplug 3 · libmodplug 2</a:t>
+            </a:r>
+          </a:p>
+        </p:txBody>
+      </p:sp>
+      <p:sp>
+        <p:nvSpPr>
+          <p:cNvPr id="25" name="TextBox 24"/>
+          <p:cNvSpPr txBox="1"/>
+          <p:nvPr/>
+        </p:nvSpPr>
+        <p:spPr>
+          <a:xfrm>
+            <a:off x="6053328" y="6552819"/>
+            <a:ext cx="5650992" cy="182880"/>
+          </a:xfrm>
+          <a:prstGeom prst="rect">
+            <a:avLst/>
+          </a:prstGeom>
+          <a:noFill/>
+        </p:spPr>
+        <p:txBody>
+          <a:bodyPr wrap="square" anchor="t" lIns="25400" rIns="25400" tIns="12700" bIns="12700">
+            <a:spAutoFit/>
+          </a:bodyPr>
+          <a:lstStyle/>
+          <a:p>
+            <a:pPr algn="ctr">
+              <a:lnSpc>
+                <a:spcPct val="100000"/>
+              </a:lnSpc>
+            </a:pPr>
+            <a:r>
+              <a:rPr sz="850" b="0">
+                <a:solidFill>
+                  <a:srgbClr val="5A6573"/>
+                </a:solidFill>
+                <a:latin typeface="Calibri"/>
+              </a:rPr>
+              <a:t>▶  embedded  ·  embargoed, coordinated disclosure</a:t>
             </a:r>
           </a:p>
         </p:txBody>

</xml_diff>